<commit_message>
Moved Gardener into a separate slide-deck and enhanced it
</commit_message>
<xml_diff>
--- a/docker/02_Docker_Fundamentals.pptx
+++ b/docker/02_Docker_Fundamentals.pptx
@@ -5164,18 +5164,9 @@
               <a:buChar char="-"/>
             </a:pPr>
             <a:r>
-              <a:rPr lang="en-US" dirty="0" err="1"/>
-              <a:t>coreOS</a:t>
-            </a:r>
-            <a:r>
               <a:rPr lang="en-US" dirty="0"/>
-              <a:t> – container </a:t>
-            </a:r>
-            <a:r>
-              <a:rPr lang="en-US" dirty="0" err="1"/>
-              <a:t>linux</a:t>
-            </a:r>
-            <a:endParaRPr lang="en-US" dirty="0"/>
+              <a:t>Atomic host by RedHat</a:t>
+            </a:r>
           </a:p>
           <a:p>
             <a:pPr marL="285750" indent="-285750">
@@ -5183,8 +5174,20 @@
               <a:buChar char="-"/>
             </a:pPr>
             <a:r>
+              <a:rPr lang="en-US" dirty="0" err="1"/>
+              <a:t>Gardenlinux</a:t>
+            </a:r>
+            <a:r>
               <a:rPr lang="en-US" dirty="0"/>
-              <a:t>Atomic host by RedHat</a:t>
+              <a:t> by </a:t>
+            </a:r>
+            <a:r>
+              <a:rPr lang="en-US" dirty="0" err="1"/>
+              <a:t>Gardener@SAP</a:t>
+            </a:r>
+            <a:r>
+              <a:rPr lang="en-US" dirty="0"/>
+              <a:t> (https://gardenlinux.io/ and https://github.com/gardenlinux)</a:t>
             </a:r>
           </a:p>
           <a:p>
@@ -5976,7 +5979,7 @@
   <p:clrMapOvr>
     <a:masterClrMapping/>
   </p:clrMapOvr>
-  <p:extLst mod="1">
+  <p:extLst>
     <p:ext uri="{DCECCB84-F9BA-43D5-87BE-67443E8EF086}">
       <p15:sldGuideLst xmlns:p15="http://schemas.microsoft.com/office/powerpoint/2012/main"/>
     </p:ext>
@@ -8629,7 +8632,7 @@
   <p:clrMapOvr>
     <a:masterClrMapping/>
   </p:clrMapOvr>
-  <p:extLst mod="1">
+  <p:extLst>
     <p:ext uri="{DCECCB84-F9BA-43D5-87BE-67443E8EF086}">
       <p15:sldGuideLst xmlns:p15="http://schemas.microsoft.com/office/powerpoint/2012/main"/>
     </p:ext>
@@ -8806,7 +8809,7 @@
   <p:clrMapOvr>
     <a:masterClrMapping/>
   </p:clrMapOvr>
-  <p:extLst mod="1">
+  <p:extLst>
     <p:ext uri="{DCECCB84-F9BA-43D5-87BE-67443E8EF086}">
       <p15:sldGuideLst xmlns:p15="http://schemas.microsoft.com/office/powerpoint/2012/main"/>
     </p:ext>
@@ -16747,7 +16750,7 @@
   <p:clrMapOvr>
     <a:masterClrMapping/>
   </p:clrMapOvr>
-  <p:extLst mod="1">
+  <p:extLst>
     <p:ext uri="{DCECCB84-F9BA-43D5-87BE-67443E8EF086}">
       <p15:sldGuideLst xmlns:p15="http://schemas.microsoft.com/office/powerpoint/2012/main"/>
     </p:ext>
@@ -17172,7 +17175,7 @@
   <p:clrMapOvr>
     <a:masterClrMapping/>
   </p:clrMapOvr>
-  <p:extLst mod="1">
+  <p:extLst>
     <p:ext uri="{DCECCB84-F9BA-43D5-87BE-67443E8EF086}">
       <p15:sldGuideLst xmlns:p15="http://schemas.microsoft.com/office/powerpoint/2012/main"/>
     </p:ext>
@@ -18600,7 +18603,7 @@
       </a:lvl9pPr>
     </p:otherStyle>
   </p:txStyles>
-  <p:extLst mod="1">
+  <p:extLst>
     <p:ext uri="{27BBF7A9-308A-43DC-89C8-2F10F3537804}">
       <p15:sldGuideLst xmlns:p15="http://schemas.microsoft.com/office/powerpoint/2012/main"/>
     </p:ext>
@@ -42251,9 +42254,7 @@
             <p:nvPr/>
           </p:nvPicPr>
           <p:blipFill>
-            <a:blip r:embed="rId4">
-              <a:extLst/>
-            </a:blip>
+            <a:blip r:embed="rId4"/>
             <a:stretch>
               <a:fillRect/>
             </a:stretch>
@@ -42911,8 +42912,8 @@
         </p:blipFill>
         <p:spPr bwMode="auto">
           <a:xfrm>
-            <a:off x="8995909" y="1914411"/>
-            <a:ext cx="1506374" cy="1200078"/>
+            <a:off x="9280015" y="4358066"/>
+            <a:ext cx="930816" cy="741552"/>
           </a:xfrm>
           <a:prstGeom prst="rect">
             <a:avLst/>
@@ -42958,55 +42959,8 @@
         </p:blipFill>
         <p:spPr bwMode="auto">
           <a:xfrm>
-            <a:off x="9193956" y="3492220"/>
-            <a:ext cx="1101867" cy="1101867"/>
-          </a:xfrm>
-          <a:prstGeom prst="rect">
-            <a:avLst/>
-          </a:prstGeom>
-          <a:noFill/>
-          <a:extLst>
-            <a:ext uri="{909E8E84-426E-40DD-AFC4-6F175D3DCCD1}">
-              <a14:hiddenFill xmlns:a14="http://schemas.microsoft.com/office/drawing/2010/main">
-                <a:solidFill>
-                  <a:srgbClr val="FFFFFF"/>
-                </a:solidFill>
-              </a14:hiddenFill>
-            </a:ext>
-          </a:extLst>
-        </p:spPr>
-      </p:pic>
-      <p:pic>
-        <p:nvPicPr>
-          <p:cNvPr id="1036" name="Picture 12" descr="Image result for core os">
-            <a:extLst>
-              <a:ext uri="{FF2B5EF4-FFF2-40B4-BE49-F238E27FC236}">
-                <a16:creationId xmlns:a16="http://schemas.microsoft.com/office/drawing/2014/main" id="{EBEAD15C-C228-41A8-AA12-5D908811BD04}"/>
-              </a:ext>
-            </a:extLst>
-          </p:cNvPr>
-          <p:cNvPicPr>
-            <a:picLocks noChangeAspect="1" noChangeArrowheads="1"/>
-          </p:cNvPicPr>
-          <p:nvPr/>
-        </p:nvPicPr>
-        <p:blipFill>
-          <a:blip r:embed="rId12">
-            <a:extLst>
-              <a:ext uri="{28A0092B-C50C-407E-A947-70E740481C1C}">
-                <a14:useLocalDpi xmlns:a14="http://schemas.microsoft.com/office/drawing/2010/main" val="0"/>
-              </a:ext>
-            </a:extLst>
-          </a:blip>
-          <a:srcRect/>
-          <a:stretch>
-            <a:fillRect/>
-          </a:stretch>
-        </p:blipFill>
-        <p:spPr bwMode="auto">
-          <a:xfrm>
-            <a:off x="9319192" y="4971818"/>
-            <a:ext cx="851397" cy="1101868"/>
+            <a:off x="9354772" y="5343787"/>
+            <a:ext cx="773628" cy="773630"/>
           </a:xfrm>
           <a:prstGeom prst="rect">
             <a:avLst/>
@@ -43199,6 +43153,43 @@
           </a:p>
         </p:txBody>
       </p:sp>
+      <p:pic>
+        <p:nvPicPr>
+          <p:cNvPr id="13" name="Graphic 12">
+            <a:hlinkClick r:id="rId12"/>
+            <a:extLst>
+              <a:ext uri="{FF2B5EF4-FFF2-40B4-BE49-F238E27FC236}">
+                <a16:creationId xmlns:a16="http://schemas.microsoft.com/office/drawing/2014/main" id="{F12AB2B9-C176-4913-A91C-40B7077737A2}"/>
+              </a:ext>
+            </a:extLst>
+          </p:cNvPr>
+          <p:cNvPicPr>
+            <a:picLocks noChangeAspect="1"/>
+          </p:cNvPicPr>
+          <p:nvPr/>
+        </p:nvPicPr>
+        <p:blipFill>
+          <a:blip r:embed="rId13">
+            <a:extLst>
+              <a:ext uri="{96DAC541-7B7A-43D3-8B79-37D633B846F1}">
+                <asvg:svgBlip xmlns:asvg="http://schemas.microsoft.com/office/drawing/2016/SVG/main" r:embed="rId14"/>
+              </a:ext>
+            </a:extLst>
+          </a:blip>
+          <a:stretch>
+            <a:fillRect/>
+          </a:stretch>
+        </p:blipFill>
+        <p:spPr>
+          <a:xfrm>
+            <a:off x="8582699" y="1796124"/>
+            <a:ext cx="2317774" cy="2317774"/>
+          </a:xfrm>
+          <a:prstGeom prst="rect">
+            <a:avLst/>
+          </a:prstGeom>
+        </p:spPr>
+      </p:pic>
     </p:spTree>
     <p:extLst>
       <p:ext uri="{BB962C8B-B14F-4D97-AF65-F5344CB8AC3E}">
@@ -43959,6 +43950,15 @@
 </file>
 
 <file path=customXml/item1.xml><?xml version="1.0" encoding="utf-8"?>
+<?mso-contentType ?>
+<FormTemplates xmlns="http://schemas.microsoft.com/sharepoint/v3/contenttype/forms">
+  <Display>DocumentLibraryForm</Display>
+  <Edit>DocumentLibraryForm</Edit>
+  <New>DocumentLibraryForm</New>
+</FormTemplates>
+</file>
+
+<file path=customXml/item2.xml><?xml version="1.0" encoding="utf-8"?>
 <ct:contentTypeSchema xmlns:ct="http://schemas.microsoft.com/office/2006/metadata/contentType" xmlns:ma="http://schemas.microsoft.com/office/2006/metadata/properties/metaAttributes" ct:_="" ma:_="" ma:contentTypeName="Document" ma:contentTypeID="0x010100413C8A4F00697141B6FA960F762861E8" ma:contentTypeVersion="7" ma:contentTypeDescription="Create a new document." ma:contentTypeScope="" ma:versionID="75679eb20af3838b1eab1fbe72fef032">
   <xsd:schema xmlns:xsd="http://www.w3.org/2001/XMLSchema" xmlns:xs="http://www.w3.org/2001/XMLSchema" xmlns:p="http://schemas.microsoft.com/office/2006/metadata/properties" xmlns:ns3="49a59b68-094c-48f7-af2b-0072ac24b77e" targetNamespace="http://schemas.microsoft.com/office/2006/metadata/properties" ma:root="true" ma:fieldsID="223f61b356e47f140bcb594d278c0c55" ns3:_="">
     <xsd:import namespace="49a59b68-094c-48f7-af2b-0072ac24b77e"/>
@@ -44122,15 +44122,6 @@
 </ct:contentTypeSchema>
 </file>
 
-<file path=customXml/item2.xml><?xml version="1.0" encoding="utf-8"?>
-<?mso-contentType ?>
-<FormTemplates xmlns="http://schemas.microsoft.com/sharepoint/v3/contenttype/forms">
-  <Display>DocumentLibraryForm</Display>
-  <Edit>DocumentLibraryForm</Edit>
-  <New>DocumentLibraryForm</New>
-</FormTemplates>
-</file>
-
 <file path=customXml/item3.xml><?xml version="1.0" encoding="utf-8"?>
 <p:properties xmlns:p="http://schemas.microsoft.com/office/2006/metadata/properties" xmlns:xsi="http://www.w3.org/2001/XMLSchema-instance" xmlns:pc="http://schemas.microsoft.com/office/infopath/2007/PartnerControls">
   <documentManagement/>
@@ -44138,6 +44129,14 @@
 </file>
 
 <file path=customXml/itemProps1.xml><?xml version="1.0" encoding="utf-8"?>
+<ds:datastoreItem xmlns:ds="http://schemas.openxmlformats.org/officeDocument/2006/customXml" ds:itemID="{C2223F73-0F08-4D22-88C9-602F4313BC72}">
+  <ds:schemaRefs>
+    <ds:schemaRef ds:uri="http://schemas.microsoft.com/sharepoint/v3/contenttype/forms"/>
+  </ds:schemaRefs>
+</ds:datastoreItem>
+</file>
+
+<file path=customXml/itemProps2.xml><?xml version="1.0" encoding="utf-8"?>
 <ds:datastoreItem xmlns:ds="http://schemas.openxmlformats.org/officeDocument/2006/customXml" ds:itemID="{9234AC07-8006-4F61-93F8-4AB6A04320B1}">
   <ds:schemaRefs>
     <ds:schemaRef ds:uri="http://schemas.microsoft.com/office/2006/metadata/contentType"/>
@@ -44151,14 +44150,6 @@
     <ds:schemaRef ds:uri="http://purl.org/dc/elements/1.1/"/>
     <ds:schemaRef ds:uri="http://purl.org/dc/terms/"/>
     <ds:schemaRef ds:uri="http://schemas.microsoft.com/internal/obd"/>
-  </ds:schemaRefs>
-</ds:datastoreItem>
-</file>
-
-<file path=customXml/itemProps2.xml><?xml version="1.0" encoding="utf-8"?>
-<ds:datastoreItem xmlns:ds="http://schemas.openxmlformats.org/officeDocument/2006/customXml" ds:itemID="{C2223F73-0F08-4D22-88C9-602F4313BC72}">
-  <ds:schemaRefs>
-    <ds:schemaRef ds:uri="http://schemas.microsoft.com/sharepoint/v3/contenttype/forms"/>
   </ds:schemaRefs>
 </ds:datastoreItem>
 </file>

</xml_diff>